<commit_message>
Correct the dense-search description in the deck and report
Embedded Qdrant scores every vector exhaustively; it does not use an
HNSW graph. The syllabus slide (Module 2), the CO4 card and the
report's syllabus table now describe retrieval as cosine and BM25
ranking with rank fusion and best-first top-k pruning, matching the
technical spec.

Co-Authored-By: Claude Opus 5.5 <noreply@anthropic.com>
</commit_message>
<xml_diff>
--- a/docs/presentation/Course_Notes_RAG_Demo.pptx
+++ b/docs/presentation/Course_Notes_RAG_Demo.pptx
@@ -123,41 +123,41 @@
   <p:extLst>
     <p:ext uri="{521415D9-36F7-43E2-AB2F-B90AF26B5E84}">
       <p14:sectionLst xmlns:p14="http://schemas.microsoft.com/office/powerpoint/2010/main">
-        <p14:section name="Introduction" id="{13a6b8f2-8804-ff1f-ad14-686237c05e02}">
+        <p14:section name="Introduction" id="{5c08b441-d165-08d7-b6ed-a12f59ee069f}">
           <p14:sldIdLst>
             <p14:sldId id="256"/>
             <p14:sldId id="257"/>
             <p14:sldId id="258"/>
           </p14:sldIdLst>
         </p14:section>
-        <p14:section name="System" id="{8c251018-9530-1884-27d7-78f600df60c6}">
+        <p14:section name="System" id="{4318d8b8-03bb-fc2e-42ce-c31325e3cb27}">
           <p14:sldIdLst>
             <p14:sldId id="259"/>
             <p14:sldId id="260"/>
             <p14:sldId id="261"/>
           </p14:sldIdLst>
         </p14:section>
-        <p14:section name="Features" id="{5f791043-f0e4-666c-e8dc-e92f59ca3895}">
+        <p14:section name="Features" id="{19e7a173-9447-194a-43cc-20adf02acf86}">
           <p14:sldIdLst>
             <p14:sldId id="262"/>
             <p14:sldId id="263"/>
             <p14:sldId id="264"/>
           </p14:sldIdLst>
         </p14:section>
-        <p14:section name="Evaluation" id="{4fe09fbc-0421-ae5f-acd6-c72b56e47afc}">
+        <p14:section name="Evaluation" id="{afa56549-cb0d-36ec-e445-90b8eadd664d}">
           <p14:sldIdLst>
             <p14:sldId id="265"/>
             <p14:sldId id="266"/>
           </p14:sldIdLst>
         </p14:section>
-        <p14:section name="Syllabus" id="{b44831b3-a480-27c7-baf4-6a8bb6cfdd9d}">
+        <p14:section name="Syllabus" id="{0953e2cb-b671-3888-b8ac-732034e72e28}">
           <p14:sldIdLst>
             <p14:sldId id="267"/>
             <p14:sldId id="268"/>
             <p14:sldId id="269"/>
           </p14:sldIdLst>
         </p14:section>
-        <p14:section name="Wrap-up" id="{b4218203-4db6-5ce6-83a1-944bdfe43e67}">
+        <p14:section name="Wrap-up" id="{46a318d1-4bcf-5b70-5f04-0611afad1618}">
           <p14:sldIdLst>
             <p14:sldId id="270"/>
             <p14:sldId id="271"/>
@@ -7094,7 +7094,7 @@
                           <a:ea typeface="Calibri" pitchFamily="34" charset="-122"/>
                           <a:cs typeface="Calibri" pitchFamily="34" charset="-120"/>
                         </a:rPr>
-                        <a:t>Retrieval is search over a space of passages: Qdrant's HNSW index runs greedy best-first search on vector distance; BM25 and RRF rank and prune candidates to the top 15 / top 5.</a:t>
+                        <a:t>Retrieval is search over a space of passages: cosine and BM25 scores order the frontier, RRF fuses the rankings, and best-first pruning keeps 25 → 15 → 5 for the costly cross-encoder.</a:t>
                       </a:r>
                       <a:endParaRPr lang="en-US" sz="1000" dirty="0">
                         <a:latin typeface="Calibri" charset="0"/>
@@ -10108,7 +10108,7 @@
                   <a:schemeClr val="tx2"/>
                 </a:solidFill>
               </a:rPr>
-              <a:t>Best-first vector search, BM25 ranking, rank fusion and top-k pruning decide what the model is allowed to say.</a:t>
+              <a:t>Ranked vector and BM25 search, rank fusion and top-k pruning decide what the model is allowed to say.</a:t>
             </a:r>
             <a:endParaRPr lang="en-US" sz="1100" dirty="0"/>
           </a:p>

</xml_diff>

<commit_message>
Add Pranali Kamisetty's registration number
24BDS0326 replaces the placeholder on the deck's title and closing
slides and in the report's author block, and is added to the README.

export_pdf.ps1 now exports from a temporary copy, so a copy of the file
open in Office no longer blocks it, and it only quits PowerPoint or Word
when it started them itself, so it cannot close the user's own window.

Co-Authored-By: Claude Opus 5.5 <noreply@anthropic.com>
</commit_message>
<xml_diff>
--- a/docs/presentation/Course_Notes_RAG_Demo.pptx
+++ b/docs/presentation/Course_Notes_RAG_Demo.pptx
@@ -123,41 +123,41 @@
   <p:extLst>
     <p:ext uri="{521415D9-36F7-43E2-AB2F-B90AF26B5E84}">
       <p14:sectionLst xmlns:p14="http://schemas.microsoft.com/office/powerpoint/2010/main">
-        <p14:section name="Introduction" id="{5c08b441-d165-08d7-b6ed-a12f59ee069f}">
+        <p14:section name="Introduction" id="{96899ddf-5e73-4781-52c9-72e18fab0e17}">
           <p14:sldIdLst>
             <p14:sldId id="256"/>
             <p14:sldId id="257"/>
             <p14:sldId id="258"/>
           </p14:sldIdLst>
         </p14:section>
-        <p14:section name="System" id="{4318d8b8-03bb-fc2e-42ce-c31325e3cb27}">
+        <p14:section name="System" id="{ade93ee2-7938-d4d2-c8a4-a345c031666c}">
           <p14:sldIdLst>
             <p14:sldId id="259"/>
             <p14:sldId id="260"/>
             <p14:sldId id="261"/>
           </p14:sldIdLst>
         </p14:section>
-        <p14:section name="Features" id="{19e7a173-9447-194a-43cc-20adf02acf86}">
+        <p14:section name="Features" id="{a58f8b2a-5999-766e-9371-eeb4266393cc}">
           <p14:sldIdLst>
             <p14:sldId id="262"/>
             <p14:sldId id="263"/>
             <p14:sldId id="264"/>
           </p14:sldIdLst>
         </p14:section>
-        <p14:section name="Evaluation" id="{afa56549-cb0d-36ec-e445-90b8eadd664d}">
+        <p14:section name="Evaluation" id="{001a4ed0-191d-ff1b-80ec-31f21432061b}">
           <p14:sldIdLst>
             <p14:sldId id="265"/>
             <p14:sldId id="266"/>
           </p14:sldIdLst>
         </p14:section>
-        <p14:section name="Syllabus" id="{0953e2cb-b671-3888-b8ac-732034e72e28}">
+        <p14:section name="Syllabus" id="{13344263-94ed-8ea5-c9e6-6d7c5a9086ac}">
           <p14:sldIdLst>
             <p14:sldId id="267"/>
             <p14:sldId id="268"/>
             <p14:sldId id="269"/>
           </p14:sldIdLst>
         </p14:section>
-        <p14:section name="Wrap-up" id="{46a318d1-4bcf-5b70-5f04-0611afad1618}">
+        <p14:section name="Wrap-up" id="{c2171ead-4262-c449-8262-f63da56d4136}">
           <p14:sldIdLst>
             <p14:sldId id="270"/>
             <p14:sldId id="271"/>
@@ -3744,7 +3744,7 @@
                   <a:schemeClr val="bg1"/>
                 </a:solidFill>
               </a:rPr>
-              <a:t>Pranali Kamisetty ([Registration Number])</a:t>
+              <a:t>Pranali Kamisetty (24BDS0326)</a:t>
             </a:r>
             <a:endParaRPr lang="en-US" sz="1100" dirty="0"/>
           </a:p>
@@ -11739,7 +11739,7 @@
                   <a:schemeClr val="bg1"/>
                 </a:solidFill>
               </a:rPr>
-              <a:t>Royce B Selvaraj (24BCB0078)  ·  Srujan Buddharaju (24BDS0347)  ·  Pranali Kamisetty ([Registration Number])</a:t>
+              <a:t>Royce B Selvaraj (24BCB0078)  ·  Srujan Buddharaju (24BDS0347)  ·  Pranali Kamisetty (24BDS0326)</a:t>
             </a:r>
             <a:endParaRPr lang="en-US" sz="1200" dirty="0"/>
           </a:p>

</xml_diff>